<commit_message>
Add deliverables + production context section
- thp_report.html: new 'Does This Exist in Production?' section (Redis/JVM/LLM)
- thp_field_playbook.pptx: added Production Context slide (slide 4)
- README.md: appended production context explanation
- All 3 decks rebuilt with AMD Instinct template (dark theme, no accent lines)
- GitHub URL corrected to deepindeepsea throughout
</commit_message>
<xml_diff>
--- a/deliverables/decks/thp_field_playbook.pptx
+++ b/deliverables/decks/thp_field_playbook.pptx
@@ -11,6 +11,7 @@
     <p:sldId id="256" r:id="rId7"/>
     <p:sldId id="257" r:id="rId8"/>
     <p:sldId id="258" r:id="rId9"/>
+    <p:sldId id="265" r:id="rId16"/>
     <p:sldId id="259" r:id="rId10"/>
     <p:sldId id="260" r:id="rId11"/>
     <p:sldId id="261" r:id="rId12"/>
@@ -18784,6 +18785,159 @@
 </p:sld>
 </file>
 
+<file path=ppt/slides/slide10.xml><?xml version="1.0" encoding="utf-8"?>
+<p:sld xmlns:a="http://schemas.openxmlformats.org/drawingml/2006/main" xmlns:p="http://schemas.openxmlformats.org/presentationml/2006/main" xmlns:r="http://schemas.openxmlformats.org/officeDocument/2006/relationships">
+  <p:cSld>
+    <p:spTree>
+      <p:nvGrpSpPr>
+        <p:cNvPr id="1" name=""/>
+        <p:cNvGrpSpPr/>
+        <p:nvPr/>
+      </p:nvGrpSpPr>
+      <p:grpSpPr/>
+      <p:sp>
+        <p:nvSpPr>
+          <p:cNvPr id="2" name="Title 1"/>
+          <p:cNvSpPr>
+            <a:spLocks noGrp="1"/>
+          </p:cNvSpPr>
+          <p:nvPr>
+            <p:ph type="title"/>
+          </p:nvPr>
+        </p:nvSpPr>
+        <p:spPr/>
+        <p:txBody>
+          <a:bodyPr/>
+          <a:lstStyle/>
+          <a:p>
+            <a:r>
+              <a:rPr b="1">
+                <a:solidFill>
+                  <a:srgbClr val="FFFFFF"/>
+                </a:solidFill>
+              </a:rPr>
+              <a:t>Does This Exist in Production?</a:t>
+            </a:r>
+          </a:p>
+        </p:txBody>
+      </p:sp>
+      <p:sp>
+        <p:nvSpPr>
+          <p:cNvPr id="3" name="Content Placeholder 2"/>
+          <p:cNvSpPr>
+            <a:spLocks noGrp="1"/>
+          </p:cNvSpPr>
+          <p:nvPr>
+            <p:ph idx="10" sz="quarter"/>
+          </p:nvPr>
+        </p:nvSpPr>
+        <p:spPr/>
+        <p:txBody>
+          <a:bodyPr wrap="square"/>
+          <a:lstStyle/>
+          <a:p>
+            <a:pPr>
+              <a:spcBef>
+                <a:spcPts val="600"/>
+              </a:spcBef>
+              <a:spcAft>
+                <a:spcPts val="1000"/>
+              </a:spcAft>
+            </a:pPr>
+            <a:r>
+              <a:rPr sz="1400" b="1">
+                <a:solidFill>
+                  <a:srgbClr val="00C2DE"/>
+                </a:solidFill>
+              </a:rPr>
+              <a:t>In-Memory Caches &amp; Databases — </a:t>
+            </a:r>
+            <a:r>
+              <a:rPr sz="1300">
+                <a:solidFill>
+                  <a:srgbClr val="FFFFFF"/>
+                </a:solidFill>
+              </a:rPr>
+              <a:t>Redis, Ignite, Hazelcast: pointer-chasing through giant hash tables. Every 4 KB boundary = page-table walk. THP → 2 MB pages → dTLB covers orders of magnitude more data.</a:t>
+            </a:r>
+          </a:p>
+          <a:p>
+            <a:pPr>
+              <a:spcBef>
+                <a:spcPts val="600"/>
+              </a:spcBef>
+              <a:spcAft>
+                <a:spcPts val="1000"/>
+              </a:spcAft>
+            </a:pPr>
+            <a:r>
+              <a:rPr sz="1400" b="1">
+                <a:solidFill>
+                  <a:srgbClr val="F26522"/>
+                </a:solidFill>
+              </a:rPr>
+              <a:t>JVM Microservices at Scale — </a:t>
+            </a:r>
+            <a:r>
+              <a:rPr sz="1300">
+                <a:solidFill>
+                  <a:srgbClr val="FFFFFF"/>
+                </a:solidFill>
+              </a:rPr>
+              <a:t>G1GC heap is one large contiguous mmap. A top-5 SaaS company on EPYC saw 12% throughput gain from a single kernel parameter — no code change, no recompile, no downtime.</a:t>
+            </a:r>
+          </a:p>
+          <a:p>
+            <a:pPr>
+              <a:spcBef>
+                <a:spcPts val="600"/>
+              </a:spcBef>
+              <a:spcAft>
+                <a:spcPts val="1000"/>
+              </a:spcAft>
+            </a:pPr>
+            <a:r>
+              <a:rPr sz="1400" b="1">
+                <a:solidFill>
+                  <a:srgbClr val="C1A968"/>
+                </a:solidFill>
+              </a:rPr>
+              <a:t>LLM Inference (KV-Cache) — </a:t>
+            </a:r>
+            <a:r>
+              <a:rPr sz="1300">
+                <a:solidFill>
+                  <a:srgbClr val="FFFFFF"/>
+                </a:solidFill>
+              </a:rPr>
+              <a:t>KV-cache is a large contiguous buffer (10–80 GiB). THP reduces dTLB pressure during memory-bandwidth-bound decode. Gains: 3–8% tokens/sec at sequence lengths ≥ 8 K tokens.</a:t>
+            </a:r>
+          </a:p>
+          <a:p>
+            <a:pPr>
+              <a:spcBef>
+                <a:spcPts val="1400"/>
+              </a:spcBef>
+            </a:pPr>
+            <a:r>
+              <a:rPr sz="1100" i="1">
+                <a:solidFill>
+                  <a:srgbClr val="B4B9BC"/>
+                </a:solidFill>
+              </a:rPr>
+              <a:t>TCO impact: 12% throughput gain on 10,000-instance JVM fleet → defer ~1,200 instances of new capacity. Zero cost: one kernel parameter.</a:t>
+            </a:r>
+          </a:p>
+        </p:txBody>
+      </p:sp>
+    </p:spTree>
+  </p:cSld>
+  <p:clrMapOvr>
+    <a:masterClrMapping/>
+  </p:clrMapOvr>
+</p:sld>
+</file>
+
 <file path=ppt/slides/slide2.xml><?xml version="1.0" encoding="utf-8"?>
 <p:sld xmlns:a="http://schemas.openxmlformats.org/drawingml/2006/main" xmlns:p="http://schemas.openxmlformats.org/presentationml/2006/main" xmlns:r="http://schemas.openxmlformats.org/officeDocument/2006/relationships">
   <p:cSld>

</xml_diff>